<commit_message>
CLV report - aba TRADES (deck + report/pptx)
</commit_message>
<xml_diff>
--- a/clv-report/clv-deck.pptx
+++ b/clv-report/clv-deck.pptx
@@ -4522,7 +4522,7 @@
             <a:pPr/>
             <a:r>
               <a:rPr/>
-              <a:t>n8n: self-hosted cloud instance ~_x0000_–40/month (workflow automation — handles trigger logic, contact sync, unsubscribe webhook)</a:t>
+              <a:t>n8n: self-hosted cloud instance approx. USD 20-40/month (workflow automation — handles trigger logic, contact sync, unsubscribe webhook)</a:t>
             </a:r>
           </a:p>
           <a:p>
@@ -4536,7 +4536,7 @@
             <a:pPr/>
             <a:r>
               <a:rPr/>
-              <a:t>Total MVP run cost: under _x0000_ for the trial period</a:t>
+              <a:t>Total MVP run cost: under USD 100 for the trial period</a:t>
             </a:r>
           </a:p>
         </p:txBody>

</xml_diff>